<commit_message>
Update KMS final poster pptx with user's 15:27 revision
Co-Authored-By: Claude Opus 5.5 <noreply@anthropic.com>
</commit_message>
<xml_diff>
--- a/poster/2026_LM4p_LAI/final/poster_2026_KMS_final.pptx
+++ b/poster/2026_LM4p_LAI/final/poster_2026_KMS_final.pptx
@@ -1003,7 +1003,7 @@
         <p:spPr>
           <a:xfrm>
             <a:off x="914400" y="31772351"/>
-            <a:ext cx="14919840" cy="18473928"/>
+            <a:ext cx="14919840" cy="17568419"/>
           </a:xfrm>
           <a:prstGeom prst="rect">
             <a:avLst/>
@@ -1411,13 +1411,19 @@
               <a:t>해 연구 수행</a:t>
             </a:r>
             <a:r>
-              <a:rPr lang="en-US" altLang="ko-KR" sz="2500" b="1" dirty="0">
+              <a:rPr lang="en-US" altLang="ko-KR" sz="2500" b="1">
                 <a:solidFill>
                   <a:schemeClr val="tx2"/>
                 </a:solidFill>
               </a:rPr>
               <a:t>.</a:t>
             </a:r>
+          </a:p>
+          <a:p>
+            <a:pPr marL="457200" indent="-457200">
+              <a:buFont typeface="Wingdings" pitchFamily="2" charset="2"/>
+              <a:buChar char="§"/>
+            </a:pPr>
             <a:endParaRPr lang="en-US" sz="2800" b="1" dirty="0">
               <a:solidFill>
                 <a:schemeClr val="tx2"/>
@@ -1483,6 +1489,17 @@
               <a:buFont typeface="Wingdings" pitchFamily="2" charset="2"/>
               <a:buChar char="§"/>
             </a:pPr>
+            <a:endParaRPr lang="en-US" altLang="ko-KR" sz="2500" b="0" dirty="0">
+              <a:solidFill>
+                <a:schemeClr val="tx2"/>
+              </a:solidFill>
+            </a:endParaRPr>
+          </a:p>
+          <a:p>
+            <a:pPr marL="457200" indent="-457200">
+              <a:buFont typeface="Wingdings" pitchFamily="2" charset="2"/>
+              <a:buChar char="§"/>
+            </a:pPr>
             <a:r>
               <a:rPr lang="en-US" sz="2500" b="0" dirty="0" err="1">
                 <a:solidFill>
@@ -1627,6 +1644,20 @@
               </a:rPr>
               <a:t> 내포</a:t>
             </a:r>
+            <a:r>
+              <a:rPr lang="en-US" altLang="ko-KR" sz="2500" b="0" dirty="0">
+                <a:solidFill>
+                  <a:schemeClr val="tx2"/>
+                </a:solidFill>
+              </a:rPr>
+              <a:t>.</a:t>
+            </a:r>
+          </a:p>
+          <a:p>
+            <a:pPr marL="457200" indent="-457200">
+              <a:buFont typeface="Wingdings" pitchFamily="2" charset="2"/>
+              <a:buChar char="§"/>
+            </a:pPr>
             <a:endParaRPr lang="en-US" altLang="ko-KR" sz="2800" b="0" dirty="0">
               <a:solidFill>
                 <a:schemeClr val="tx2"/>
@@ -2916,7 +2947,7 @@
         </p:nvSpPr>
         <p:spPr>
           <a:xfrm>
-            <a:off x="1188720" y="42498264"/>
+            <a:off x="1188720" y="43074336"/>
             <a:ext cx="14374367" cy="1188720"/>
           </a:xfrm>
           <a:prstGeom prst="rect">
@@ -2952,7 +2983,7 @@
         </p:nvSpPr>
         <p:spPr>
           <a:xfrm>
-            <a:off x="1188720" y="43778424"/>
+            <a:off x="1188720" y="44354496"/>
             <a:ext cx="14374367" cy="3747597"/>
           </a:xfrm>
           <a:prstGeom prst="rect">
@@ -4168,7 +4199,7 @@
         </p:blipFill>
         <p:spPr>
           <a:xfrm>
-            <a:off x="3108960" y="31891224"/>
+            <a:off x="3108960" y="32467296"/>
             <a:ext cx="10515600" cy="10515600"/>
           </a:xfrm>
           <a:prstGeom prst="rect">

</xml_diff>